<commit_message>
Build Session 16 and publish CP7 for solo founders
CP7 is now due Fri, Oct 30 (CP7_DUE), so a solo founder starts the
front door in the Session 16 workshop and finishes it outside class.
The setup guide becomes a placeholder until there's code to set up;
the full guide and its cold test move to Session 20.

- CP7 rubric rewritten student-facing and published. A missing
  partner read caps Newcomer usability at Proficient.
- Submission: tag main as cp7, then submit the tag URL and a photo
  of the Stranger's Read sheet (Canvas text entry).
- Session 16: outline v2, deck (tools/build-session16.js), student
  page, and the Stranger's Read half-sheet.
- Session 15 page, outline, and deck updated to match.
- demos/prop-loft-states: Prop Loft's session tags, plus the scripts
  that publish the states and seed a tag's issues.

Co-Authored-By: Claude Opus 5.5 (1M context) <noreply@anthropic.com>
</commit_message>
<xml_diff>
--- a/canvas_material/lectures/powerpoint/Session15-FrontDoor.pptx
+++ b/canvas_material/lectures/powerpoint/Session15-FrontDoor.pptx
@@ -524,7 +524,7 @@
           <a:p>
             <a:r>
               <a:rPr lang="en-US" dirty="0"/>
-              <a:t>First half of Week 8. Session 3 was why governance matters; Session 13 set the workflow. Today it all becomes files a stranger reads. Before class: open tabs for Textualize/rich, dagorym/SSW, and (optional) prop-loft/prop-loft, plus the bug-report bank in the outline's Appendix. Have the CP7 Checklist printed, one per student, and the License Cheat Sheet page up. Wednesday is the build workshop; CP7 is due end of day Wednesday.</a:t>
+              <a:t>First half of Week 8. Session 3 was why governance matters; Session 13 set the workflow. Today it all becomes files a stranger reads. Before class: open tabs for Textualize/rich, dagorym/SSW, and (optional) prop-loft/prop-loft, plus the bug-report bank in the outline's Appendix. Have the CP7 Checklist printed, one per student, and the License Cheat Sheet page up. Wednesday is the build workshop; CP7 is due end of day Friday, Oct 30.</a:t>
             </a:r>
             <a:endParaRPr lang="en-US" dirty="0"/>
           </a:p>
@@ -1844,7 +1844,7 @@
           <a:p>
             <a:r>
               <a:rPr lang="en-US" dirty="0"/>
-              <a:t>Close in a few minutes. Say the one-liner, then the logistics. The cold tester is the item that stalls projects on Wednesday if nobody's arranged it: the setup guide has to be followed by someone who didn't write it, from a fresh clone, and the failures filed as issues. Solo founders use their review partner. CP9 opens today: anything good they write from now on can go in the portfolio, so tell them to save links as they go.</a:t>
+              <a:t>Close in a few minutes. Say the one-liner, then the logistics. Wednesday starts every piece of CP7 and finishes the quick ones; the rest is due Friday, so nobody has to build the whole front door alone in 75 minutes. The review partner matters: after the fast items, partners read each other's README and CONTRIBUTING cold. The setup guide is only a placeholder for now; say so, so nobody spends Tuesday night writing setup steps for code that doesn't exist. CP9 opens today: anything good they write from now on can go in the portfolio, so tell them to save links as they go.</a:t>
             </a:r>
             <a:endParaRPr lang="en-US" dirty="0"/>
           </a:p>
@@ -2372,7 +2372,7 @@
           <a:p>
             <a:r>
               <a:rPr lang="en-US" dirty="0"/>
-              <a:t>Two minutes. Five parts, in this order, because it's the order of the stranger's questions. The highlighted two do the most work: the first line, and a quickstart that works on a machine that isn't yours. Read Prop Loft's first sentence aloud as an example if you opened the tab. The amber card sets up the self-audit: every project will write its first sentence before leaving today, and most will rewrite it.</a:t>
+              <a:t>Two minutes. Five parts, in this order, because it's the order of the stranger's questions. The highlighted two do the most work: the first line, and a quickstart that works on a machine that isn't yours. Their repos have nothing to run until the build starts, so for CP7 the honest version is a status line and a pointer to a setup placeholder, docs/setup.md: the stack, 'instructions arrive with the first runnable build,' and a link to the issue tracking it. The real setup guide is written and partner-tested in Session 20. A broken quickstart is worse than an honest 'not yet.' Read Prop Loft's first sentence aloud as an example if you opened the tab. The amber card sets up the self-audit: every project will write its first sentence before leaving today, and most will rewrite it.</a:t>
             </a:r>
             <a:endParaRPr lang="en-US" dirty="0"/>
           </a:p>
@@ -16173,7 +16173,7 @@
                 <a:ea typeface="Calibri" pitchFamily="34" charset="-122"/>
                 <a:cs typeface="Calibri" pitchFamily="34" charset="-120"/>
               </a:rPr>
-              <a:t>Line up a cold tester: someone who didn't write your setup guide (solo: your review partner)</a:t>
+              <a:t>Bring your review partner's repo link: you'll read each other's README cold</a:t>
             </a:r>
             <a:endParaRPr lang="en-US" sz="1700" dirty="0"/>
           </a:p>
@@ -16259,7 +16259,7 @@
                 <a:ea typeface="Calibri" pitchFamily="34" charset="-122"/>
                 <a:cs typeface="Calibri" pitchFamily="34" charset="-120"/>
               </a:rPr>
-              <a:t>CP7 is due end of day Wednesday, merged to main. CP9 (eight artifacts) is due Nov 18.</a:t>
+              <a:t>CP7 is due end of day Friday, Oct 30, merged to main. CP9 (eight artifacts) is due Nov 18.</a:t>
             </a:r>
             <a:endParaRPr lang="en-US" sz="1600" dirty="0"/>
           </a:p>
@@ -22196,7 +22196,7 @@
                 <a:ea typeface="Calibri" pitchFamily="34" charset="-122"/>
                 <a:cs typeface="Calibri" pitchFamily="34" charset="-120"/>
               </a:rPr>
-              <a:t>From a fresh clone, on someone else's machine</a:t>
+              <a:t>Nothing runs yet? Say so, and point to docs/setup.md</a:t>
             </a:r>
             <a:endParaRPr lang="en-US" sz="1700" dirty="0"/>
           </a:p>

</xml_diff>